<commit_message>
Add ICSIGT 2026 conference poster (36x48 in) with QR codes
Populates the organisers' template with DRISHTI: nine figures generated at
print size from the project's own result files (evaluation.json, metrics.json,
validation.json), so no figure can drift from the measured numbers.

- build_poster_charts.py renders the figures light-themed to match the template
- build_poster.py fills the template in place, leaving its logos, section bars
  and colour scheme untouched
- QR codes link to the live dashboard and the source repo; both URLs verified
  to return 200 and both codes verified to decode correctly

The template itself is gitignored on the same grounds as the problem
statement: it is the organisers' document, not ours to redistribute.

Co-Authored-By: Claude Opus 5 <noreply@anthropic.com>
</commit_message>
<xml_diff>
--- a/drishti/poster/DRISHTI_Poster_ICSIGT2026_EcoGenesis.pptx
+++ b/drishti/poster/DRISHTI_Poster_ICSIGT2026_EcoGenesis.pptx
@@ -1,20 +1,20 @@
 
 <file path=ppt/presentation.xml><?xml version="1.0" encoding="utf-8"?>
-<p:presentation xmlns:a="http://schemas.openxmlformats.org/drawingml/2006/main" xmlns:r="http://schemas.openxmlformats.org/officeDocument/2006/relationships" xmlns:p="http://schemas.openxmlformats.org/presentationml/2006/main" strictFirstAndLastChars="0" saveSubsetFonts="1" autoCompressPictures="0">
+<p:presentation xmlns:a="http://schemas.openxmlformats.org/drawingml/2006/main" xmlns:r="http://schemas.openxmlformats.org/officeDocument/2006/relationships" xmlns:mc="http://schemas.openxmlformats.org/markup-compatibility/2006" xmlns:mv="urn:schemas-microsoft-com:mac:vml" xmlns:p="http://schemas.openxmlformats.org/presentationml/2006/main" xmlns:c="http://schemas.openxmlformats.org/drawingml/2006/chart" xmlns:dgm="http://schemas.openxmlformats.org/drawingml/2006/diagram" xmlns:o="urn:schemas-microsoft-com:office:office" xmlns:v="urn:schemas-microsoft-com:vml" xmlns:pvml="urn:schemas-microsoft-com:office:powerpoint" xmlns:com="http://schemas.openxmlformats.org/drawingml/2006/compatibility" xmlns:p14="http://schemas.microsoft.com/office/powerpoint/2010/main" xmlns:p15="http://schemas.microsoft.com/office/powerpoint/2012/main" xmlns:ahyp="http://schemas.microsoft.com/office/drawing/2018/hyperlinkcolor" autoCompressPictures="0" strictFirstAndLastChars="0" saveSubsetFonts="1">
   <p:sldMasterIdLst>
-    <p:sldMasterId id="2147483648" r:id="rId1"/>
+    <p:sldMasterId id="2147483648" r:id="rId4"/>
   </p:sldMasterIdLst>
   <p:sldIdLst>
-    <p:sldId id="256" r:id="rId2"/>
+    <p:sldId id="256" r:id="rId5"/>
   </p:sldIdLst>
-  <p:sldSz cx="32918400" cy="43891200"/>
+  <p:sldSz cy="43891200" cx="32918400"/>
   <p:notesSz cx="6858000" cy="9144000"/>
   <p:defaultTextStyle>
     <a:defPPr lvl="0">
       <a:defRPr lang="en-US"/>
     </a:defPPr>
-    <a:lvl1pPr marL="0" lvl="0" algn="l" defTabSz="457200" rtl="0" eaLnBrk="1" latinLnBrk="0" hangingPunct="1">
-      <a:defRPr sz="1800" kern="1200">
+    <a:lvl1pPr defTabSz="457200" eaLnBrk="1" hangingPunct="1" latinLnBrk="0" lvl="0" marL="0" rtl="0" algn="l">
+      <a:defRPr kern="1200" sz="1800">
         <a:solidFill>
           <a:schemeClr val="tx1"/>
         </a:solidFill>
@@ -23,8 +23,8 @@
         <a:cs typeface="+mn-cs"/>
       </a:defRPr>
     </a:lvl1pPr>
-    <a:lvl2pPr marL="457200" lvl="1" algn="l" defTabSz="457200" rtl="0" eaLnBrk="1" latinLnBrk="0" hangingPunct="1">
-      <a:defRPr sz="1800" kern="1200">
+    <a:lvl2pPr defTabSz="457200" eaLnBrk="1" hangingPunct="1" latinLnBrk="0" lvl="1" marL="457200" rtl="0" algn="l">
+      <a:defRPr kern="1200" sz="1800">
         <a:solidFill>
           <a:schemeClr val="tx1"/>
         </a:solidFill>
@@ -33,8 +33,8 @@
         <a:cs typeface="+mn-cs"/>
       </a:defRPr>
     </a:lvl2pPr>
-    <a:lvl3pPr marL="914400" lvl="2" algn="l" defTabSz="457200" rtl="0" eaLnBrk="1" latinLnBrk="0" hangingPunct="1">
-      <a:defRPr sz="1800" kern="1200">
+    <a:lvl3pPr defTabSz="457200" eaLnBrk="1" hangingPunct="1" latinLnBrk="0" lvl="2" marL="914400" rtl="0" algn="l">
+      <a:defRPr kern="1200" sz="1800">
         <a:solidFill>
           <a:schemeClr val="tx1"/>
         </a:solidFill>
@@ -43,8 +43,8 @@
         <a:cs typeface="+mn-cs"/>
       </a:defRPr>
     </a:lvl3pPr>
-    <a:lvl4pPr marL="1371600" lvl="3" algn="l" defTabSz="457200" rtl="0" eaLnBrk="1" latinLnBrk="0" hangingPunct="1">
-      <a:defRPr sz="1800" kern="1200">
+    <a:lvl4pPr defTabSz="457200" eaLnBrk="1" hangingPunct="1" latinLnBrk="0" lvl="3" marL="1371600" rtl="0" algn="l">
+      <a:defRPr kern="1200" sz="1800">
         <a:solidFill>
           <a:schemeClr val="tx1"/>
         </a:solidFill>
@@ -53,8 +53,8 @@
         <a:cs typeface="+mn-cs"/>
       </a:defRPr>
     </a:lvl4pPr>
-    <a:lvl5pPr marL="1828800" lvl="4" algn="l" defTabSz="457200" rtl="0" eaLnBrk="1" latinLnBrk="0" hangingPunct="1">
-      <a:defRPr sz="1800" kern="1200">
+    <a:lvl5pPr defTabSz="457200" eaLnBrk="1" hangingPunct="1" latinLnBrk="0" lvl="4" marL="1828800" rtl="0" algn="l">
+      <a:defRPr kern="1200" sz="1800">
         <a:solidFill>
           <a:schemeClr val="tx1"/>
         </a:solidFill>
@@ -63,8 +63,8 @@
         <a:cs typeface="+mn-cs"/>
       </a:defRPr>
     </a:lvl5pPr>
-    <a:lvl6pPr marL="2286000" lvl="5" algn="l" defTabSz="457200" rtl="0" eaLnBrk="1" latinLnBrk="0" hangingPunct="1">
-      <a:defRPr sz="1800" kern="1200">
+    <a:lvl6pPr defTabSz="457200" eaLnBrk="1" hangingPunct="1" latinLnBrk="0" lvl="5" marL="2286000" rtl="0" algn="l">
+      <a:defRPr kern="1200" sz="1800">
         <a:solidFill>
           <a:schemeClr val="tx1"/>
         </a:solidFill>
@@ -73,8 +73,8 @@
         <a:cs typeface="+mn-cs"/>
       </a:defRPr>
     </a:lvl6pPr>
-    <a:lvl7pPr marL="2743200" lvl="6" algn="l" defTabSz="457200" rtl="0" eaLnBrk="1" latinLnBrk="0" hangingPunct="1">
-      <a:defRPr sz="1800" kern="1200">
+    <a:lvl7pPr defTabSz="457200" eaLnBrk="1" hangingPunct="1" latinLnBrk="0" lvl="6" marL="2743200" rtl="0" algn="l">
+      <a:defRPr kern="1200" sz="1800">
         <a:solidFill>
           <a:schemeClr val="tx1"/>
         </a:solidFill>
@@ -83,8 +83,8 @@
         <a:cs typeface="+mn-cs"/>
       </a:defRPr>
     </a:lvl7pPr>
-    <a:lvl8pPr marL="3200400" lvl="7" algn="l" defTabSz="457200" rtl="0" eaLnBrk="1" latinLnBrk="0" hangingPunct="1">
-      <a:defRPr sz="1800" kern="1200">
+    <a:lvl8pPr defTabSz="457200" eaLnBrk="1" hangingPunct="1" latinLnBrk="0" lvl="7" marL="3200400" rtl="0" algn="l">
+      <a:defRPr kern="1200" sz="1800">
         <a:solidFill>
           <a:schemeClr val="tx1"/>
         </a:solidFill>
@@ -93,8 +93,8 @@
         <a:cs typeface="+mn-cs"/>
       </a:defRPr>
     </a:lvl8pPr>
-    <a:lvl9pPr marL="3657600" lvl="8" algn="l" defTabSz="457200" rtl="0" eaLnBrk="1" latinLnBrk="0" hangingPunct="1">
-      <a:defRPr sz="1800" kern="1200">
+    <a:lvl9pPr defTabSz="457200" eaLnBrk="1" hangingPunct="1" latinLnBrk="0" lvl="8" marL="3657600" rtl="0" algn="l">
+      <a:defRPr kern="1200" sz="1800">
         <a:solidFill>
           <a:schemeClr val="tx1"/>
         </a:solidFill>
@@ -106,7 +106,7 @@
   </p:defaultTextStyle>
   <p:extLst>
     <p:ext uri="{EFAFB233-063F-42B5-8137-9DF3F51BA10A}">
-      <p15:sldGuideLst xmlns:p15="http://schemas.microsoft.com/office/powerpoint/2012/main">
+      <p15:sldGuideLst>
         <p15:guide id="1" orient="horz" pos="2160">
           <p15:clr>
             <a:srgbClr val="A4A3A4"/>
@@ -121,6 +121,30 @@
     </p:ext>
   </p:extLst>
 </p:presentation>
+</file>
+
+<file path=ppt/presProps1.xml><?xml version="1.0" encoding="utf-8"?>
+<p:presentationPr xmlns:a="http://schemas.openxmlformats.org/drawingml/2006/main" xmlns:r="http://schemas.openxmlformats.org/officeDocument/2006/relationships" xmlns:mc="http://schemas.openxmlformats.org/markup-compatibility/2006" xmlns:mv="urn:schemas-microsoft-com:mac:vml" xmlns:p="http://schemas.openxmlformats.org/presentationml/2006/main" xmlns:c="http://schemas.openxmlformats.org/drawingml/2006/chart" xmlns:dgm="http://schemas.openxmlformats.org/drawingml/2006/diagram" xmlns:o="urn:schemas-microsoft-com:office:office" xmlns:v="urn:schemas-microsoft-com:vml" xmlns:pvml="urn:schemas-microsoft-com:office:powerpoint" xmlns:com="http://schemas.openxmlformats.org/drawingml/2006/compatibility" xmlns:p14="http://schemas.microsoft.com/office/powerpoint/2010/main" xmlns:p15="http://schemas.microsoft.com/office/powerpoint/2012/main" xmlns:ahyp="http://schemas.microsoft.com/office/drawing/2018/hyperlinkcolor"/>
+</file>
+
+<file path=ppt/viewProps1.xml><?xml version="1.0" encoding="utf-8"?>
+<p:viewPr xmlns:a="http://schemas.openxmlformats.org/drawingml/2006/main" xmlns:r="http://schemas.openxmlformats.org/officeDocument/2006/relationships" xmlns:mc="http://schemas.openxmlformats.org/markup-compatibility/2006" xmlns:mv="urn:schemas-microsoft-com:mac:vml" xmlns:p="http://schemas.openxmlformats.org/presentationml/2006/main" xmlns:c="http://schemas.openxmlformats.org/drawingml/2006/chart" xmlns:dgm="http://schemas.openxmlformats.org/drawingml/2006/diagram" xmlns:o="urn:schemas-microsoft-com:office:office" xmlns:v="urn:schemas-microsoft-com:vml" xmlns:pvml="urn:schemas-microsoft-com:office:powerpoint" xmlns:com="http://schemas.openxmlformats.org/drawingml/2006/compatibility" xmlns:p14="http://schemas.microsoft.com/office/powerpoint/2010/main" xmlns:p15="http://schemas.microsoft.com/office/powerpoint/2012/main" xmlns:ahyp="http://schemas.microsoft.com/office/drawing/2018/hyperlinkcolor" showComments="0">
+  <p:slideViewPr>
+    <p:cSldViewPr snapToGrid="0">
+      <p:cViewPr varScale="1">
+        <p:scale>
+          <a:sx n="100" d="100"/>
+          <a:sy n="100" d="100"/>
+        </p:scale>
+        <p:origin x="0" y="0"/>
+      </p:cViewPr>
+      <p:guideLst>
+        <p:guide pos="2160" orient="horz"/>
+        <p:guide pos="2880"/>
+      </p:guideLst>
+    </p:cSldViewPr>
+  </p:slideViewPr>
+</p:viewPr>
 </file>
 
 <file path=ppt/slideLayouts/slideLayout1.xml><?xml version="1.0" encoding="utf-8"?>
@@ -302,7 +326,7 @@
           <a:p>
             <a:fld id="{5BCAD085-E8A6-8845-BD4E-CB4CCA059FC4}" type="datetimeFigureOut">
               <a:rPr lang="en-US" smtClean="0"/>
-              <a:t>8/31/2026</a:t>
+              <a:t>8/30/26</a:t>
             </a:fld>
             <a:endParaRPr lang="en-US"/>
           </a:p>
@@ -470,7 +494,7 @@
           <a:p>
             <a:fld id="{5BCAD085-E8A6-8845-BD4E-CB4CCA059FC4}" type="datetimeFigureOut">
               <a:rPr lang="en-US" smtClean="0"/>
-              <a:t>8/31/2026</a:t>
+              <a:t>8/30/26</a:t>
             </a:fld>
             <a:endParaRPr lang="en-US"/>
           </a:p>
@@ -648,7 +672,7 @@
           <a:p>
             <a:fld id="{5BCAD085-E8A6-8845-BD4E-CB4CCA059FC4}" type="datetimeFigureOut">
               <a:rPr lang="en-US" smtClean="0"/>
-              <a:t>8/31/2026</a:t>
+              <a:t>8/30/26</a:t>
             </a:fld>
             <a:endParaRPr lang="en-US"/>
           </a:p>
@@ -816,7 +840,7 @@
           <a:p>
             <a:fld id="{5BCAD085-E8A6-8845-BD4E-CB4CCA059FC4}" type="datetimeFigureOut">
               <a:rPr lang="en-US" smtClean="0"/>
-              <a:t>8/31/2026</a:t>
+              <a:t>8/30/26</a:t>
             </a:fld>
             <a:endParaRPr lang="en-US"/>
           </a:p>
@@ -1061,7 +1085,7 @@
           <a:p>
             <a:fld id="{5BCAD085-E8A6-8845-BD4E-CB4CCA059FC4}" type="datetimeFigureOut">
               <a:rPr lang="en-US" smtClean="0"/>
-              <a:t>8/31/2026</a:t>
+              <a:t>8/30/26</a:t>
             </a:fld>
             <a:endParaRPr lang="en-US"/>
           </a:p>
@@ -1346,7 +1370,7 @@
           <a:p>
             <a:fld id="{5BCAD085-E8A6-8845-BD4E-CB4CCA059FC4}" type="datetimeFigureOut">
               <a:rPr lang="en-US" smtClean="0"/>
-              <a:t>8/31/2026</a:t>
+              <a:t>8/30/26</a:t>
             </a:fld>
             <a:endParaRPr lang="en-US"/>
           </a:p>
@@ -1765,7 +1789,7 @@
           <a:p>
             <a:fld id="{5BCAD085-E8A6-8845-BD4E-CB4CCA059FC4}" type="datetimeFigureOut">
               <a:rPr lang="en-US" smtClean="0"/>
-              <a:t>8/31/2026</a:t>
+              <a:t>8/30/26</a:t>
             </a:fld>
             <a:endParaRPr lang="en-US"/>
           </a:p>
@@ -1882,7 +1906,7 @@
           <a:p>
             <a:fld id="{5BCAD085-E8A6-8845-BD4E-CB4CCA059FC4}" type="datetimeFigureOut">
               <a:rPr lang="en-US" smtClean="0"/>
-              <a:t>8/31/2026</a:t>
+              <a:t>8/30/26</a:t>
             </a:fld>
             <a:endParaRPr lang="en-US"/>
           </a:p>
@@ -1977,7 +2001,7 @@
           <a:p>
             <a:fld id="{5BCAD085-E8A6-8845-BD4E-CB4CCA059FC4}" type="datetimeFigureOut">
               <a:rPr lang="en-US" smtClean="0"/>
-              <a:t>8/31/2026</a:t>
+              <a:t>8/30/26</a:t>
             </a:fld>
             <a:endParaRPr lang="en-US"/>
           </a:p>
@@ -2252,7 +2276,7 @@
           <a:p>
             <a:fld id="{5BCAD085-E8A6-8845-BD4E-CB4CCA059FC4}" type="datetimeFigureOut">
               <a:rPr lang="en-US" smtClean="0"/>
-              <a:t>8/31/2026</a:t>
+              <a:t>8/30/26</a:t>
             </a:fld>
             <a:endParaRPr lang="en-US"/>
           </a:p>
@@ -2504,7 +2528,7 @@
           <a:p>
             <a:fld id="{5BCAD085-E8A6-8845-BD4E-CB4CCA059FC4}" type="datetimeFigureOut">
               <a:rPr lang="en-US" smtClean="0"/>
-              <a:t>8/31/2026</a:t>
+              <a:t>8/30/26</a:t>
             </a:fld>
             <a:endParaRPr lang="en-US"/>
           </a:p>
@@ -2715,7 +2739,7 @@
           <a:p>
             <a:fld id="{5BCAD085-E8A6-8845-BD4E-CB4CCA059FC4}" type="datetimeFigureOut">
               <a:rPr lang="en-US" smtClean="0"/>
-              <a:t>8/31/2026</a:t>
+              <a:t>8/30/26</a:t>
             </a:fld>
             <a:endParaRPr lang="en-US"/>
           </a:p>
@@ -3278,8 +3302,8 @@
         </p:nvSpPr>
         <p:spPr>
           <a:xfrm>
-            <a:off x="4572000" y="4733688"/>
-            <a:ext cx="23774400" cy="764761"/>
+            <a:off x="4572000" y="4864608"/>
+            <a:ext cx="23774400" cy="502920"/>
           </a:xfrm>
           <a:prstGeom prst="rect">
             <a:avLst/>
@@ -3301,74 +3325,14 @@
               </a:spcAft>
             </a:pPr>
             <a:r>
-              <a:rPr sz="1800" b="1" dirty="0">
+              <a:rPr sz="1800" b="1">
                 <a:solidFill>
                   <a:srgbClr val="083070"/>
                 </a:solidFill>
                 <a:latin typeface="Arial"/>
               </a:rPr>
-              <a:t>Email: </a:t>
-            </a:r>
-            <a:r>
-              <a:rPr sz="1800" b="1" dirty="0">
-                <a:solidFill>
-                  <a:srgbClr val="083070"/>
-                </a:solidFill>
-                <a:latin typeface="Arial"/>
-                <a:hlinkClick r:id="rId2"/>
-              </a:rPr>
-              <a:t>g.vyas@op.iitg.ac.in</a:t>
-            </a:r>
-            <a:r>
-              <a:rPr lang="en-US" sz="1800" b="1" dirty="0">
-                <a:solidFill>
-                  <a:srgbClr val="083070"/>
-                </a:solidFill>
-                <a:latin typeface="Arial"/>
-              </a:rPr>
-              <a:t> ,</a:t>
-            </a:r>
-            <a:r>
-              <a:rPr lang="en-US" sz="1800" b="1" dirty="0">
-                <a:solidFill>
-                  <a:srgbClr val="083070"/>
-                </a:solidFill>
-                <a:latin typeface="Arial"/>
-                <a:hlinkClick r:id="rId3"/>
-              </a:rPr>
-              <a:t>s.mandavi@op.iitg.ac.in</a:t>
-            </a:r>
-            <a:endParaRPr lang="en-US" sz="1800" b="1" dirty="0">
-              <a:solidFill>
-                <a:srgbClr val="083070"/>
-              </a:solidFill>
-              <a:latin typeface="Arial"/>
-            </a:endParaRPr>
-          </a:p>
-          <a:p>
-            <a:pPr algn="ctr">
-              <a:lnSpc>
-                <a:spcPct val="112000"/>
-              </a:lnSpc>
-              <a:spcAft>
-                <a:spcPts val="600"/>
-              </a:spcAft>
-            </a:pPr>
-            <a:r>
-              <a:rPr lang="en-US" sz="1800" b="1" dirty="0">
-                <a:solidFill>
-                  <a:srgbClr val="083070"/>
-                </a:solidFill>
-                <a:latin typeface="Arial"/>
-              </a:rPr>
-              <a:t> </a:t>
-            </a:r>
-            <a:endParaRPr sz="1800" b="1" dirty="0">
-              <a:solidFill>
-                <a:srgbClr val="083070"/>
-              </a:solidFill>
-              <a:latin typeface="Arial"/>
-            </a:endParaRPr>
+              <a:t>g.vyas@op.iitg.ac.in   ·   s.mandavi@op.iitg.ac.in</a:t>
+            </a:r>
           </a:p>
         </p:txBody>
       </p:sp>
@@ -3624,12 +3588,15 @@
                 <a:spcPts val="1300"/>
               </a:spcAft>
             </a:pPr>
-            <a:endParaRPr sz="1950" b="1">
-              <a:solidFill>
-                <a:srgbClr val="083070"/>
-              </a:solidFill>
-              <a:latin typeface="Arial"/>
-            </a:endParaRPr>
+            <a:r>
+              <a:rPr sz="950" b="0">
+                <a:solidFill>
+                  <a:srgbClr val="6E6E6E"/>
+                </a:solidFill>
+                <a:latin typeface="Arial"/>
+              </a:rPr>
+              <a:t/>
+            </a:r>
           </a:p>
           <a:p>
             <a:pPr algn="l">
@@ -4149,7 +4116,15 @@
                 <a:spcPts val="600"/>
               </a:spcAft>
             </a:pPr>
-            <a:endParaRPr/>
+            <a:r>
+              <a:rPr sz="1200" b="0">
+                <a:solidFill>
+                  <a:srgbClr val="6E6E6E"/>
+                </a:solidFill>
+                <a:latin typeface="Arial"/>
+              </a:rPr>
+              <a:t/>
+            </a:r>
           </a:p>
         </p:txBody>
       </p:sp>
@@ -4574,7 +4549,15 @@
                 <a:spcPts val="600"/>
               </a:spcAft>
             </a:pPr>
-            <a:endParaRPr/>
+            <a:r>
+              <a:rPr sz="1200" b="0">
+                <a:solidFill>
+                  <a:srgbClr val="6E6E6E"/>
+                </a:solidFill>
+                <a:latin typeface="Arial"/>
+              </a:rPr>
+              <a:t/>
+            </a:r>
           </a:p>
         </p:txBody>
       </p:sp>
@@ -4735,7 +4718,15 @@
                 <a:spcPts val="600"/>
               </a:spcAft>
             </a:pPr>
-            <a:endParaRPr/>
+            <a:r>
+              <a:rPr sz="1200" b="0">
+                <a:solidFill>
+                  <a:srgbClr val="6E6E6E"/>
+                </a:solidFill>
+                <a:latin typeface="Arial"/>
+              </a:rPr>
+              <a:t/>
+            </a:r>
           </a:p>
         </p:txBody>
       </p:sp>
@@ -4896,7 +4887,15 @@
                 <a:spcPts val="600"/>
               </a:spcAft>
             </a:pPr>
-            <a:endParaRPr/>
+            <a:r>
+              <a:rPr sz="1200" b="0">
+                <a:solidFill>
+                  <a:srgbClr val="6E6E6E"/>
+                </a:solidFill>
+                <a:latin typeface="Arial"/>
+              </a:rPr>
+              <a:t/>
+            </a:r>
           </a:p>
         </p:txBody>
       </p:sp>
@@ -5103,7 +5102,15 @@
                 <a:spcPts val="600"/>
               </a:spcAft>
             </a:pPr>
-            <a:endParaRPr/>
+            <a:r>
+              <a:rPr sz="1200" b="0">
+                <a:solidFill>
+                  <a:srgbClr val="6E6E6E"/>
+                </a:solidFill>
+                <a:latin typeface="Arial"/>
+              </a:rPr>
+              <a:t/>
+            </a:r>
           </a:p>
         </p:txBody>
       </p:sp>
@@ -5225,7 +5232,15 @@
                 <a:spcPts val="600"/>
               </a:spcAft>
             </a:pPr>
-            <a:endParaRPr/>
+            <a:r>
+              <a:rPr sz="1200" b="0">
+                <a:solidFill>
+                  <a:srgbClr val="6E6E6E"/>
+                </a:solidFill>
+                <a:latin typeface="Arial"/>
+              </a:rPr>
+              <a:t/>
+            </a:r>
           </a:p>
         </p:txBody>
       </p:sp>
@@ -5347,7 +5362,15 @@
                 <a:spcPts val="600"/>
               </a:spcAft>
             </a:pPr>
-            <a:endParaRPr/>
+            <a:r>
+              <a:rPr sz="1200" b="0">
+                <a:solidFill>
+                  <a:srgbClr val="6E6E6E"/>
+                </a:solidFill>
+                <a:latin typeface="Arial"/>
+              </a:rPr>
+              <a:t/>
+            </a:r>
           </a:p>
         </p:txBody>
       </p:sp>
@@ -5972,13 +5995,13 @@
               </a:spcAft>
             </a:pPr>
             <a:r>
-              <a:rPr sz="1800" b="0">
+              <a:rPr sz="1700" b="0">
                 <a:solidFill>
                   <a:srgbClr val="6E6E6E"/>
                 </a:solidFill>
                 <a:latin typeface="Arial"/>
               </a:rPr>
-              <a:t>Submitted to the 1st International Conference on Sustainable Innovation and Green Technologies (ICSIGT 2026), AVINYA 2026 Eco-Innovate Challenge, organised by the Prakriti Club.</a:t>
+              <a:t>Submitted to ICSIGT 2026 · AVINYA 2026 Eco-Innovate Challenge, organised by the Prakriti Club, IIT Guwahati.</a:t>
             </a:r>
           </a:p>
           <a:p>
@@ -5990,12 +6013,15 @@
                 <a:spcPts val="600"/>
               </a:spcAft>
             </a:pPr>
-            <a:endParaRPr sz="1800" b="0">
-              <a:solidFill>
-                <a:srgbClr val="6E6E6E"/>
-              </a:solidFill>
-              <a:latin typeface="Arial"/>
-            </a:endParaRPr>
+            <a:r>
+              <a:rPr sz="1700" b="0">
+                <a:solidFill>
+                  <a:srgbClr val="6E6E6E"/>
+                </a:solidFill>
+                <a:latin typeface="Arial"/>
+              </a:rPr>
+              <a:t>We thank the OpenStreetMap contributors, Open-Meteo and the USGS for the open data this work rests on.</a:t>
+            </a:r>
           </a:p>
           <a:p>
             <a:pPr algn="l">
@@ -6007,48 +6033,13 @@
               </a:spcAft>
             </a:pPr>
             <a:r>
-              <a:rPr sz="1800" b="0">
-                <a:solidFill>
-                  <a:srgbClr val="6E6E6E"/>
+              <a:rPr sz="1800" b="1">
+                <a:solidFill>
+                  <a:srgbClr val="083070"/>
                 </a:solidFill>
                 <a:latin typeface="Arial"/>
               </a:rPr>
-              <a:t>We gratefully acknowledge the OpenStreetMap contributors, the Open-Meteo project and the United States Geological Survey for providing the open data that makes a zero-cost humanitarian system possible.</a:t>
-            </a:r>
-          </a:p>
-          <a:p>
-            <a:pPr algn="l">
-              <a:lnSpc>
-                <a:spcPct val="112000"/>
-              </a:lnSpc>
-              <a:spcAft>
-                <a:spcPts val="600"/>
-              </a:spcAft>
-            </a:pPr>
-            <a:endParaRPr sz="1800" b="0">
-              <a:solidFill>
-                <a:srgbClr val="6E6E6E"/>
-              </a:solidFill>
-              <a:latin typeface="Arial"/>
-            </a:endParaRPr>
-          </a:p>
-          <a:p>
-            <a:pPr algn="l">
-              <a:lnSpc>
-                <a:spcPct val="112000"/>
-              </a:lnSpc>
-              <a:spcAft>
-                <a:spcPts val="600"/>
-              </a:spcAft>
-            </a:pPr>
-            <a:r>
-              <a:rPr sz="2000" b="1">
-                <a:solidFill>
-                  <a:srgbClr val="083070"/>
-                </a:solidFill>
-                <a:latin typeface="Arial"/>
-              </a:rPr>
-              <a:t>Team EcoGenesis</a:t>
+              <a:t>Team EcoGenesis  ·  MIT Licence</a:t>
             </a:r>
           </a:p>
         </p:txBody>
@@ -6351,7 +6342,7 @@
           <p:nvPr/>
         </p:nvPicPr>
         <p:blipFill>
-          <a:blip r:embed="rId4"/>
+          <a:blip r:embed="rId2"/>
           <a:stretch>
             <a:fillRect/>
           </a:stretch>
@@ -6381,7 +6372,7 @@
           <p:nvPr/>
         </p:nvPicPr>
         <p:blipFill>
-          <a:blip r:embed="rId5"/>
+          <a:blip r:embed="rId3"/>
           <a:stretch>
             <a:fillRect/>
           </a:stretch>
@@ -6513,7 +6504,7 @@
           <p:nvPr/>
         </p:nvPicPr>
         <p:blipFill>
-          <a:blip r:embed="rId6"/>
+          <a:blip r:embed="rId4"/>
           <a:stretch>
             <a:fillRect/>
           </a:stretch>
@@ -6537,7 +6528,7 @@
           <p:nvPr/>
         </p:nvPicPr>
         <p:blipFill>
-          <a:blip r:embed="rId7"/>
+          <a:blip r:embed="rId5"/>
           <a:stretch>
             <a:fillRect/>
           </a:stretch>
@@ -6561,7 +6552,7 @@
           <p:nvPr/>
         </p:nvPicPr>
         <p:blipFill>
-          <a:blip r:embed="rId8"/>
+          <a:blip r:embed="rId6"/>
           <a:stretch>
             <a:fillRect/>
           </a:stretch>
@@ -6585,7 +6576,7 @@
           <p:nvPr/>
         </p:nvPicPr>
         <p:blipFill>
-          <a:blip r:embed="rId9"/>
+          <a:blip r:embed="rId7"/>
           <a:stretch>
             <a:fillRect/>
           </a:stretch>
@@ -6609,7 +6600,7 @@
           <p:nvPr/>
         </p:nvPicPr>
         <p:blipFill>
-          <a:blip r:embed="rId10"/>
+          <a:blip r:embed="rId8"/>
           <a:stretch>
             <a:fillRect/>
           </a:stretch>
@@ -6633,7 +6624,7 @@
           <p:nvPr/>
         </p:nvPicPr>
         <p:blipFill>
-          <a:blip r:embed="rId11"/>
+          <a:blip r:embed="rId9"/>
           <a:stretch>
             <a:fillRect/>
           </a:stretch>
@@ -6657,7 +6648,7 @@
           <p:nvPr/>
         </p:nvPicPr>
         <p:blipFill>
-          <a:blip r:embed="rId12"/>
+          <a:blip r:embed="rId10"/>
           <a:stretch>
             <a:fillRect/>
           </a:stretch>
@@ -6681,7 +6672,7 @@
           <p:nvPr/>
         </p:nvPicPr>
         <p:blipFill>
-          <a:blip r:embed="rId13"/>
+          <a:blip r:embed="rId11"/>
           <a:stretch>
             <a:fillRect/>
           </a:stretch>
@@ -6705,6 +6696,54 @@
           <p:nvPr/>
         </p:nvPicPr>
         <p:blipFill>
+          <a:blip r:embed="rId12"/>
+          <a:stretch>
+            <a:fillRect/>
+          </a:stretch>
+        </p:blipFill>
+        <p:spPr>
+          <a:xfrm>
+            <a:off x="19880833" y="30961584"/>
+            <a:ext cx="12240261" cy="4818887"/>
+          </a:xfrm>
+          <a:prstGeom prst="rect">
+            <a:avLst/>
+          </a:prstGeom>
+        </p:spPr>
+      </p:pic>
+      <p:pic>
+        <p:nvPicPr>
+          <p:cNvPr id="79" name="Picture 78" descr="qr_demo.png"/>
+          <p:cNvPicPr>
+            <a:picLocks noChangeAspect="1"/>
+          </p:cNvPicPr>
+          <p:nvPr/>
+        </p:nvPicPr>
+        <p:blipFill>
+          <a:blip r:embed="rId13"/>
+          <a:stretch>
+            <a:fillRect/>
+          </a:stretch>
+        </p:blipFill>
+        <p:spPr>
+          <a:xfrm>
+            <a:off x="19376136" y="41074848"/>
+            <a:ext cx="1572768" cy="1572768"/>
+          </a:xfrm>
+          <a:prstGeom prst="rect">
+            <a:avLst/>
+          </a:prstGeom>
+        </p:spPr>
+      </p:pic>
+      <p:pic>
+        <p:nvPicPr>
+          <p:cNvPr id="80" name="Picture 79" descr="qr_repo.png"/>
+          <p:cNvPicPr>
+            <a:picLocks noChangeAspect="1"/>
+          </p:cNvPicPr>
+          <p:nvPr/>
+        </p:nvPicPr>
+        <p:blipFill>
           <a:blip r:embed="rId14"/>
           <a:stretch>
             <a:fillRect/>
@@ -6712,14 +6751,138 @@
         </p:blipFill>
         <p:spPr>
           <a:xfrm>
-            <a:off x="19880833" y="30961584"/>
-            <a:ext cx="12240261" cy="4818887"/>
+            <a:off x="21817584" y="41074848"/>
+            <a:ext cx="1572768" cy="1572768"/>
           </a:xfrm>
           <a:prstGeom prst="rect">
             <a:avLst/>
           </a:prstGeom>
         </p:spPr>
       </p:pic>
+      <p:sp>
+        <p:nvSpPr>
+          <p:cNvPr id="81" name="TextBox 80"/>
+          <p:cNvSpPr txBox="1"/>
+          <p:nvPr/>
+        </p:nvSpPr>
+        <p:spPr>
+          <a:xfrm>
+            <a:off x="18836640" y="42739056"/>
+            <a:ext cx="2651760" cy="868680"/>
+          </a:xfrm>
+          <a:prstGeom prst="rect">
+            <a:avLst/>
+          </a:prstGeom>
+          <a:noFill/>
+        </p:spPr>
+        <p:txBody>
+          <a:bodyPr wrap="square" anchor="t">
+            <a:spAutoFit/>
+          </a:bodyPr>
+          <a:lstStyle/>
+          <a:p>
+            <a:pPr algn="ctr">
+              <a:lnSpc>
+                <a:spcPct val="112000"/>
+              </a:lnSpc>
+              <a:spcAft>
+                <a:spcPts val="600"/>
+              </a:spcAft>
+            </a:pPr>
+            <a:r>
+              <a:rPr sz="1400" b="1">
+                <a:solidFill>
+                  <a:srgbClr val="00B050"/>
+                </a:solidFill>
+                <a:latin typeface="Arial"/>
+              </a:rPr>
+              <a:t>LIVE DASHBOARD</a:t>
+            </a:r>
+          </a:p>
+          <a:p>
+            <a:pPr algn="ctr">
+              <a:lnSpc>
+                <a:spcPct val="112000"/>
+              </a:lnSpc>
+              <a:spcAft>
+                <a:spcPts val="600"/>
+              </a:spcAft>
+            </a:pPr>
+            <a:r>
+              <a:rPr sz="1000" b="0">
+                <a:solidFill>
+                  <a:srgbClr val="6E6E6E"/>
+                </a:solidFill>
+                <a:latin typeface="Arial"/>
+              </a:rPr>
+              <a:t>realgauravvyas.github.io
+/drishti</a:t>
+            </a:r>
+          </a:p>
+        </p:txBody>
+      </p:sp>
+      <p:sp>
+        <p:nvSpPr>
+          <p:cNvPr id="82" name="TextBox 81"/>
+          <p:cNvSpPr txBox="1"/>
+          <p:nvPr/>
+        </p:nvSpPr>
+        <p:spPr>
+          <a:xfrm>
+            <a:off x="21278088" y="42739056"/>
+            <a:ext cx="2651760" cy="868680"/>
+          </a:xfrm>
+          <a:prstGeom prst="rect">
+            <a:avLst/>
+          </a:prstGeom>
+          <a:noFill/>
+        </p:spPr>
+        <p:txBody>
+          <a:bodyPr wrap="square" anchor="t">
+            <a:spAutoFit/>
+          </a:bodyPr>
+          <a:lstStyle/>
+          <a:p>
+            <a:pPr algn="ctr">
+              <a:lnSpc>
+                <a:spcPct val="112000"/>
+              </a:lnSpc>
+              <a:spcAft>
+                <a:spcPts val="600"/>
+              </a:spcAft>
+            </a:pPr>
+            <a:r>
+              <a:rPr sz="1400" b="1">
+                <a:solidFill>
+                  <a:srgbClr val="083070"/>
+                </a:solidFill>
+                <a:latin typeface="Arial"/>
+              </a:rPr>
+              <a:t>SOURCE CODE</a:t>
+            </a:r>
+          </a:p>
+          <a:p>
+            <a:pPr algn="ctr">
+              <a:lnSpc>
+                <a:spcPct val="112000"/>
+              </a:lnSpc>
+              <a:spcAft>
+                <a:spcPts val="600"/>
+              </a:spcAft>
+            </a:pPr>
+            <a:r>
+              <a:rPr sz="1000" b="0">
+                <a:solidFill>
+                  <a:srgbClr val="6E6E6E"/>
+                </a:solidFill>
+                <a:latin typeface="Arial"/>
+              </a:rPr>
+              <a:t>github.com/realgauravvyas
+/drishti</a:t>
+            </a:r>
+          </a:p>
+        </p:txBody>
+      </p:sp>
     </p:spTree>
   </p:cSld>
   <p:clrMapOvr>

</xml_diff>

<commit_message>
Fix overlapping reference-line label in the blind-spot figure
The "0.5 = coin flip" annotation sat at y=0.518, which is exactly where the
0.500 bar's own value label is drawn, so the two collided and neither read
cleanly on the printed poster.

Moved the annotation outside the axes using get_yaxis_transform(), so it
labels the right-hand end of the dashed line and cannot collide with any bar
or value label regardless of the data.

Co-Authored-By: Claude Opus 5 <noreply@anthropic.com>
</commit_message>
<xml_diff>
--- a/drishti/poster/DRISHTI_Poster_ICSIGT2026_EcoGenesis.pptx
+++ b/drishti/poster/DRISHTI_Poster_ICSIGT2026_EcoGenesis.pptx
@@ -6631,8 +6631,8 @@
         </p:blipFill>
         <p:spPr>
           <a:xfrm>
-            <a:off x="15553521" y="23143464"/>
-            <a:ext cx="7782388" cy="6281928"/>
+            <a:off x="15334488" y="23419585"/>
+            <a:ext cx="8220456" cy="5729685"/>
           </a:xfrm>
           <a:prstGeom prst="rect">
             <a:avLst/>

</xml_diff>